<commit_message>
Slide 9: replace some tables with charts (revenue/profit dynamics + cumulative discounted CF with payback point)
Co-authored-by: emikateam-coder <emikateam-coder@users.noreply.github.com>
</commit_message>
<xml_diff>
--- a/Презентация_ВКР_ВИТА_ЛАЙФ.pptx
+++ b/Презентация_ВКР_ВИТА_ЛАЙФ.pptx
@@ -6419,549 +6419,30 @@
           </a:p>
         </p:txBody>
       </p:sp>
-      <p:graphicFrame>
-        <p:nvGraphicFramePr>
-          <p:cNvPr id="3" name="Table 2"/>
-          <p:cNvGraphicFramePr>
-            <a:graphicFrameLocks noGrp="1"/>
-          </p:cNvGraphicFramePr>
+      <p:pic>
+        <p:nvPicPr>
+          <p:cNvPr id="3" name="Picture 2" descr="chart_slide9.png"/>
+          <p:cNvPicPr>
+            <a:picLocks noChangeAspect="1"/>
+          </p:cNvPicPr>
           <p:nvPr/>
-        </p:nvGraphicFramePr>
-        <p:xfrm>
-          <a:off x="216000" y="1548000"/>
-          <a:ext cx="4140000" cy="3960000"/>
-        </p:xfrm>
-        <a:graphic>
-          <a:graphicData uri="http://schemas.openxmlformats.org/drawingml/2006/table">
-            <a:tbl>
-              <a:tblPr firstRow="1" bandRow="1">
-                <a:tableStyleId>{5C22544A-7EE6-4342-B048-85BDC9FD1C3A}</a:tableStyleId>
-              </a:tblPr>
-              <a:tblGrid>
-                <a:gridCol w="1380000"/>
-                <a:gridCol w="1380000"/>
-                <a:gridCol w="1380000"/>
-              </a:tblGrid>
-              <a:tr h="330000">
-                <a:tc>
-                  <a:txBody>
-                    <a:bodyPr wrap="square"/>
-                    <a:lstStyle/>
-                    <a:p>
-                      <a:r>
-                        <a:rPr sz="1000" b="1">
-                          <a:solidFill>
-                            <a:srgbClr val="FFFFFF"/>
-                          </a:solidFill>
-                        </a:rPr>
-                        <a:t>Инвестиционные затраты</a:t>
-                      </a:r>
-                    </a:p>
-                  </a:txBody>
-                  <a:tcPr marL="36000" marR="36000" marT="18000" marB="18000">
-                    <a:solidFill>
-                      <a:srgbClr val="1F3A68"/>
-                    </a:solidFill>
-                  </a:tcPr>
-                </a:tc>
-                <a:tc>
-                  <a:txBody>
-                    <a:bodyPr wrap="square"/>
-                    <a:lstStyle/>
-                    <a:p>
-                      <a:r>
-                        <a:rPr sz="1000" b="1">
-                          <a:solidFill>
-                            <a:srgbClr val="FFFFFF"/>
-                          </a:solidFill>
-                        </a:rPr>
-                        <a:t>тыс. руб.</a:t>
-                      </a:r>
-                    </a:p>
-                  </a:txBody>
-                  <a:tcPr marL="36000" marR="36000" marT="18000" marB="18000">
-                    <a:solidFill>
-                      <a:srgbClr val="1F3A68"/>
-                    </a:solidFill>
-                  </a:tcPr>
-                </a:tc>
-                <a:tc>
-                  <a:txBody>
-                    <a:bodyPr wrap="square"/>
-                    <a:lstStyle/>
-                    <a:p>
-                      <a:r>
-                        <a:rPr sz="1000" b="1">
-                          <a:solidFill>
-                            <a:srgbClr val="FFFFFF"/>
-                          </a:solidFill>
-                        </a:rPr>
-                        <a:t>%</a:t>
-                      </a:r>
-                    </a:p>
-                  </a:txBody>
-                  <a:tcPr marL="36000" marR="36000" marT="18000" marB="18000">
-                    <a:solidFill>
-                      <a:srgbClr val="1F3A68"/>
-                    </a:solidFill>
-                  </a:tcPr>
-                </a:tc>
-              </a:tr>
-              <a:tr h="330000">
-                <a:tc>
-                  <a:txBody>
-                    <a:bodyPr wrap="square"/>
-                    <a:lstStyle/>
-                    <a:p>
-                      <a:r>
-                        <a:rPr sz="900" b="1"/>
-                        <a:t>Производственное оборудование</a:t>
-                      </a:r>
-                    </a:p>
-                  </a:txBody>
-                  <a:tcPr marL="36000" marR="36000" marT="18000" marB="18000"/>
-                </a:tc>
-                <a:tc>
-                  <a:txBody>
-                    <a:bodyPr wrap="square"/>
-                    <a:lstStyle/>
-                    <a:p>
-                      <a:r>
-                        <a:rPr sz="900"/>
-                        <a:t>28 500</a:t>
-                      </a:r>
-                    </a:p>
-                  </a:txBody>
-                  <a:tcPr marL="36000" marR="36000" marT="18000" marB="18000"/>
-                </a:tc>
-                <a:tc>
-                  <a:txBody>
-                    <a:bodyPr wrap="square"/>
-                    <a:lstStyle/>
-                    <a:p>
-                      <a:r>
-                        <a:rPr sz="900"/>
-                        <a:t>36,3</a:t>
-                      </a:r>
-                    </a:p>
-                  </a:txBody>
-                  <a:tcPr marL="36000" marR="36000" marT="18000" marB="18000"/>
-                </a:tc>
-              </a:tr>
-              <a:tr h="330000">
-                <a:tc>
-                  <a:txBody>
-                    <a:bodyPr wrap="square"/>
-                    <a:lstStyle/>
-                    <a:p>
-                      <a:r>
-                        <a:rPr sz="900" b="1"/>
-                        <a:t>Лабораторное оборудование</a:t>
-                      </a:r>
-                    </a:p>
-                  </a:txBody>
-                  <a:tcPr marL="36000" marR="36000" marT="18000" marB="18000"/>
-                </a:tc>
-                <a:tc>
-                  <a:txBody>
-                    <a:bodyPr wrap="square"/>
-                    <a:lstStyle/>
-                    <a:p>
-                      <a:r>
-                        <a:rPr sz="900"/>
-                        <a:t>3 800</a:t>
-                      </a:r>
-                    </a:p>
-                  </a:txBody>
-                  <a:tcPr marL="36000" marR="36000" marT="18000" marB="18000"/>
-                </a:tc>
-                <a:tc>
-                  <a:txBody>
-                    <a:bodyPr wrap="square"/>
-                    <a:lstStyle/>
-                    <a:p>
-                      <a:r>
-                        <a:rPr sz="900"/>
-                        <a:t>4,8</a:t>
-                      </a:r>
-                    </a:p>
-                  </a:txBody>
-                  <a:tcPr marL="36000" marR="36000" marT="18000" marB="18000"/>
-                </a:tc>
-              </a:tr>
-              <a:tr h="330000">
-                <a:tc>
-                  <a:txBody>
-                    <a:bodyPr wrap="square"/>
-                    <a:lstStyle/>
-                    <a:p>
-                      <a:r>
-                        <a:rPr sz="900" b="1"/>
-                        <a:t>Реконструкция и сети</a:t>
-                      </a:r>
-                    </a:p>
-                  </a:txBody>
-                  <a:tcPr marL="36000" marR="36000" marT="18000" marB="18000"/>
-                </a:tc>
-                <a:tc>
-                  <a:txBody>
-                    <a:bodyPr wrap="square"/>
-                    <a:lstStyle/>
-                    <a:p>
-                      <a:r>
-                        <a:rPr sz="900"/>
-                        <a:t>8 200</a:t>
-                      </a:r>
-                    </a:p>
-                  </a:txBody>
-                  <a:tcPr marL="36000" marR="36000" marT="18000" marB="18000"/>
-                </a:tc>
-                <a:tc>
-                  <a:txBody>
-                    <a:bodyPr wrap="square"/>
-                    <a:lstStyle/>
-                    <a:p>
-                      <a:r>
-                        <a:rPr sz="900"/>
-                        <a:t>10,4</a:t>
-                      </a:r>
-                    </a:p>
-                  </a:txBody>
-                  <a:tcPr marL="36000" marR="36000" marT="18000" marB="18000"/>
-                </a:tc>
-              </a:tr>
-              <a:tr h="330000">
-                <a:tc>
-                  <a:txBody>
-                    <a:bodyPr wrap="square"/>
-                    <a:lstStyle/>
-                    <a:p>
-                      <a:r>
-                        <a:rPr sz="900" b="1"/>
-                        <a:t>Оборудование 5 магазинов</a:t>
-                      </a:r>
-                    </a:p>
-                  </a:txBody>
-                  <a:tcPr marL="36000" marR="36000" marT="18000" marB="18000"/>
-                </a:tc>
-                <a:tc>
-                  <a:txBody>
-                    <a:bodyPr wrap="square"/>
-                    <a:lstStyle/>
-                    <a:p>
-                      <a:r>
-                        <a:rPr sz="900"/>
-                        <a:t>14 500</a:t>
-                      </a:r>
-                    </a:p>
-                  </a:txBody>
-                  <a:tcPr marL="36000" marR="36000" marT="18000" marB="18000"/>
-                </a:tc>
-                <a:tc>
-                  <a:txBody>
-                    <a:bodyPr wrap="square"/>
-                    <a:lstStyle/>
-                    <a:p>
-                      <a:r>
-                        <a:rPr sz="900"/>
-                        <a:t>18,5</a:t>
-                      </a:r>
-                    </a:p>
-                  </a:txBody>
-                  <a:tcPr marL="36000" marR="36000" marT="18000" marB="18000"/>
-                </a:tc>
-              </a:tr>
-              <a:tr h="330000">
-                <a:tc>
-                  <a:txBody>
-                    <a:bodyPr wrap="square"/>
-                    <a:lstStyle/>
-                    <a:p>
-                      <a:r>
-                        <a:rPr sz="900" b="1"/>
-                        <a:t>Транспорт</a:t>
-                      </a:r>
-                    </a:p>
-                  </a:txBody>
-                  <a:tcPr marL="36000" marR="36000" marT="18000" marB="18000"/>
-                </a:tc>
-                <a:tc>
-                  <a:txBody>
-                    <a:bodyPr wrap="square"/>
-                    <a:lstStyle/>
-                    <a:p>
-                      <a:r>
-                        <a:rPr sz="900"/>
-                        <a:t>5 600</a:t>
-                      </a:r>
-                    </a:p>
-                  </a:txBody>
-                  <a:tcPr marL="36000" marR="36000" marT="18000" marB="18000"/>
-                </a:tc>
-                <a:tc>
-                  <a:txBody>
-                    <a:bodyPr wrap="square"/>
-                    <a:lstStyle/>
-                    <a:p>
-                      <a:r>
-                        <a:rPr sz="900"/>
-                        <a:t>7,1</a:t>
-                      </a:r>
-                    </a:p>
-                  </a:txBody>
-                  <a:tcPr marL="36000" marR="36000" marT="18000" marB="18000"/>
-                </a:tc>
-              </a:tr>
-              <a:tr h="330000">
-                <a:tc>
-                  <a:txBody>
-                    <a:bodyPr wrap="square"/>
-                    <a:lstStyle/>
-                    <a:p>
-                      <a:r>
-                        <a:rPr sz="900" b="1"/>
-                        <a:t>Цифровизация и ИС</a:t>
-                      </a:r>
-                    </a:p>
-                  </a:txBody>
-                  <a:tcPr marL="36000" marR="36000" marT="18000" marB="18000"/>
-                </a:tc>
-                <a:tc>
-                  <a:txBody>
-                    <a:bodyPr wrap="square"/>
-                    <a:lstStyle/>
-                    <a:p>
-                      <a:r>
-                        <a:rPr sz="900"/>
-                        <a:t>4 200</a:t>
-                      </a:r>
-                    </a:p>
-                  </a:txBody>
-                  <a:tcPr marL="36000" marR="36000" marT="18000" marB="18000"/>
-                </a:tc>
-                <a:tc>
-                  <a:txBody>
-                    <a:bodyPr wrap="square"/>
-                    <a:lstStyle/>
-                    <a:p>
-                      <a:r>
-                        <a:rPr sz="900"/>
-                        <a:t>5,4</a:t>
-                      </a:r>
-                    </a:p>
-                  </a:txBody>
-                  <a:tcPr marL="36000" marR="36000" marT="18000" marB="18000"/>
-                </a:tc>
-              </a:tr>
-              <a:tr h="330000">
-                <a:tc>
-                  <a:txBody>
-                    <a:bodyPr wrap="square"/>
-                    <a:lstStyle/>
-                    <a:p>
-                      <a:r>
-                        <a:rPr sz="900" b="1"/>
-                        <a:t>Регистрация ТМ и сертификация</a:t>
-                      </a:r>
-                    </a:p>
-                  </a:txBody>
-                  <a:tcPr marL="36000" marR="36000" marT="18000" marB="18000"/>
-                </a:tc>
-                <a:tc>
-                  <a:txBody>
-                    <a:bodyPr wrap="square"/>
-                    <a:lstStyle/>
-                    <a:p>
-                      <a:r>
-                        <a:rPr sz="900"/>
-                        <a:t>1 800</a:t>
-                      </a:r>
-                    </a:p>
-                  </a:txBody>
-                  <a:tcPr marL="36000" marR="36000" marT="18000" marB="18000"/>
-                </a:tc>
-                <a:tc>
-                  <a:txBody>
-                    <a:bodyPr wrap="square"/>
-                    <a:lstStyle/>
-                    <a:p>
-                      <a:r>
-                        <a:rPr sz="900"/>
-                        <a:t>2,3</a:t>
-                      </a:r>
-                    </a:p>
-                  </a:txBody>
-                  <a:tcPr marL="36000" marR="36000" marT="18000" marB="18000"/>
-                </a:tc>
-              </a:tr>
-              <a:tr h="330000">
-                <a:tc>
-                  <a:txBody>
-                    <a:bodyPr wrap="square"/>
-                    <a:lstStyle/>
-                    <a:p>
-                      <a:r>
-                        <a:rPr sz="900" b="1"/>
-                        <a:t>Стартовый товарный запас</a:t>
-                      </a:r>
-                    </a:p>
-                  </a:txBody>
-                  <a:tcPr marL="36000" marR="36000" marT="18000" marB="18000"/>
-                </a:tc>
-                <a:tc>
-                  <a:txBody>
-                    <a:bodyPr wrap="square"/>
-                    <a:lstStyle/>
-                    <a:p>
-                      <a:r>
-                        <a:rPr sz="900"/>
-                        <a:t>4 900</a:t>
-                      </a:r>
-                    </a:p>
-                  </a:txBody>
-                  <a:tcPr marL="36000" marR="36000" marT="18000" marB="18000"/>
-                </a:tc>
-                <a:tc>
-                  <a:txBody>
-                    <a:bodyPr wrap="square"/>
-                    <a:lstStyle/>
-                    <a:p>
-                      <a:r>
-                        <a:rPr sz="900"/>
-                        <a:t>6,2</a:t>
-                      </a:r>
-                    </a:p>
-                  </a:txBody>
-                  <a:tcPr marL="36000" marR="36000" marT="18000" marB="18000"/>
-                </a:tc>
-              </a:tr>
-              <a:tr h="330000">
-                <a:tc>
-                  <a:txBody>
-                    <a:bodyPr wrap="square"/>
-                    <a:lstStyle/>
-                    <a:p>
-                      <a:r>
-                        <a:rPr sz="900" b="1"/>
-                        <a:t>Маркетинговый запуск</a:t>
-                      </a:r>
-                    </a:p>
-                  </a:txBody>
-                  <a:tcPr marL="36000" marR="36000" marT="18000" marB="18000"/>
-                </a:tc>
-                <a:tc>
-                  <a:txBody>
-                    <a:bodyPr wrap="square"/>
-                    <a:lstStyle/>
-                    <a:p>
-                      <a:r>
-                        <a:rPr sz="900"/>
-                        <a:t>3 600</a:t>
-                      </a:r>
-                    </a:p>
-                  </a:txBody>
-                  <a:tcPr marL="36000" marR="36000" marT="18000" marB="18000"/>
-                </a:tc>
-                <a:tc>
-                  <a:txBody>
-                    <a:bodyPr wrap="square"/>
-                    <a:lstStyle/>
-                    <a:p>
-                      <a:r>
-                        <a:rPr sz="900"/>
-                        <a:t>4,6</a:t>
-                      </a:r>
-                    </a:p>
-                  </a:txBody>
-                  <a:tcPr marL="36000" marR="36000" marT="18000" marB="18000"/>
-                </a:tc>
-              </a:tr>
-              <a:tr h="330000">
-                <a:tc>
-                  <a:txBody>
-                    <a:bodyPr wrap="square"/>
-                    <a:lstStyle/>
-                    <a:p>
-                      <a:r>
-                        <a:rPr sz="900" b="1"/>
-                        <a:t>Резерв непредвиденных расходов</a:t>
-                      </a:r>
-                    </a:p>
-                  </a:txBody>
-                  <a:tcPr marL="36000" marR="36000" marT="18000" marB="18000"/>
-                </a:tc>
-                <a:tc>
-                  <a:txBody>
-                    <a:bodyPr wrap="square"/>
-                    <a:lstStyle/>
-                    <a:p>
-                      <a:r>
-                        <a:rPr sz="900"/>
-                        <a:t>3 400</a:t>
-                      </a:r>
-                    </a:p>
-                  </a:txBody>
-                  <a:tcPr marL="36000" marR="36000" marT="18000" marB="18000"/>
-                </a:tc>
-                <a:tc>
-                  <a:txBody>
-                    <a:bodyPr wrap="square"/>
-                    <a:lstStyle/>
-                    <a:p>
-                      <a:r>
-                        <a:rPr sz="900"/>
-                        <a:t>4,4</a:t>
-                      </a:r>
-                    </a:p>
-                  </a:txBody>
-                  <a:tcPr marL="36000" marR="36000" marT="18000" marB="18000"/>
-                </a:tc>
-              </a:tr>
-              <a:tr h="330000">
-                <a:tc>
-                  <a:txBody>
-                    <a:bodyPr wrap="square"/>
-                    <a:lstStyle/>
-                    <a:p>
-                      <a:r>
-                        <a:rPr sz="900" b="1"/>
-                        <a:t>Итого инвестиции</a:t>
-                      </a:r>
-                    </a:p>
-                  </a:txBody>
-                  <a:tcPr marL="36000" marR="36000" marT="18000" marB="18000"/>
-                </a:tc>
-                <a:tc>
-                  <a:txBody>
-                    <a:bodyPr wrap="square"/>
-                    <a:lstStyle/>
-                    <a:p>
-                      <a:r>
-                        <a:rPr sz="900"/>
-                        <a:t>78 500</a:t>
-                      </a:r>
-                    </a:p>
-                  </a:txBody>
-                  <a:tcPr marL="36000" marR="36000" marT="18000" marB="18000"/>
-                </a:tc>
-                <a:tc>
-                  <a:txBody>
-                    <a:bodyPr wrap="square"/>
-                    <a:lstStyle/>
-                    <a:p>
-                      <a:r>
-                        <a:rPr sz="900"/>
-                        <a:t>100,0</a:t>
-                      </a:r>
-                    </a:p>
-                  </a:txBody>
-                  <a:tcPr marL="36000" marR="36000" marT="18000" marB="18000"/>
-                </a:tc>
-              </a:tr>
-            </a:tbl>
-          </a:graphicData>
-        </a:graphic>
-      </p:graphicFrame>
+        </p:nvPicPr>
+        <p:blipFill>
+          <a:blip r:embed="rId2"/>
+          <a:stretch>
+            <a:fillRect/>
+          </a:stretch>
+        </p:blipFill>
+        <p:spPr>
+          <a:xfrm>
+            <a:off x="144000" y="1440000"/>
+            <a:ext cx="8856000" cy="3129595"/>
+          </a:xfrm>
+          <a:prstGeom prst="rect">
+            <a:avLst/>
+          </a:prstGeom>
+        </p:spPr>
+      </p:pic>
       <p:graphicFrame>
         <p:nvGraphicFramePr>
           <p:cNvPr id="4" name="Table 3"/>
@@ -6971,8 +6452,8 @@
           <p:nvPr/>
         </p:nvGraphicFramePr>
         <p:xfrm>
-          <a:off x="4428000" y="1548000"/>
-          <a:ext cx="4464000" cy="1980000"/>
+          <a:off x="144000" y="4896000"/>
+          <a:ext cx="4320000" cy="1440000"/>
         </p:xfrm>
         <a:graphic>
           <a:graphicData uri="http://schemas.openxmlformats.org/drawingml/2006/table">
@@ -6981,14 +6462,10 @@
                 <a:tableStyleId>{5C22544A-7EE6-4342-B048-85BDC9FD1C3A}</a:tableStyleId>
               </a:tblPr>
               <a:tblGrid>
-                <a:gridCol w="744000"/>
-                <a:gridCol w="744000"/>
-                <a:gridCol w="744000"/>
-                <a:gridCol w="744000"/>
-                <a:gridCol w="744000"/>
-                <a:gridCol w="744000"/>
+                <a:gridCol w="2160000"/>
+                <a:gridCol w="2160000"/>
               </a:tblGrid>
-              <a:tr h="330000">
+              <a:tr h="160000">
                 <a:tc>
                   <a:txBody>
                     <a:bodyPr wrap="square"/>
@@ -7000,7 +6477,7 @@
                             <a:srgbClr val="FFFFFF"/>
                           </a:solidFill>
                         </a:rPr>
-                        <a:t>Прогноз выручки, млн руб.</a:t>
+                        <a:t>Инвестиционные затраты</a:t>
                       </a:r>
                     </a:p>
                   </a:txBody>
@@ -7021,7 +6498,7 @@
                             <a:srgbClr val="FFFFFF"/>
                           </a:solidFill>
                         </a:rPr>
-                        <a:t>1-й</a:t>
+                        <a:t>млн руб.</a:t>
                       </a:r>
                     </a:p>
                   </a:txBody>
@@ -7031,92 +6508,8 @@
                     </a:solidFill>
                   </a:tcPr>
                 </a:tc>
-                <a:tc>
-                  <a:txBody>
-                    <a:bodyPr wrap="square"/>
-                    <a:lstStyle/>
-                    <a:p>
-                      <a:r>
-                        <a:rPr sz="1000" b="1">
-                          <a:solidFill>
-                            <a:srgbClr val="FFFFFF"/>
-                          </a:solidFill>
-                        </a:rPr>
-                        <a:t>2-й</a:t>
-                      </a:r>
-                    </a:p>
-                  </a:txBody>
-                  <a:tcPr marL="36000" marR="36000" marT="18000" marB="18000">
-                    <a:solidFill>
-                      <a:srgbClr val="1F3A68"/>
-                    </a:solidFill>
-                  </a:tcPr>
-                </a:tc>
-                <a:tc>
-                  <a:txBody>
-                    <a:bodyPr wrap="square"/>
-                    <a:lstStyle/>
-                    <a:p>
-                      <a:r>
-                        <a:rPr sz="1000" b="1">
-                          <a:solidFill>
-                            <a:srgbClr val="FFFFFF"/>
-                          </a:solidFill>
-                        </a:rPr>
-                        <a:t>3-й</a:t>
-                      </a:r>
-                    </a:p>
-                  </a:txBody>
-                  <a:tcPr marL="36000" marR="36000" marT="18000" marB="18000">
-                    <a:solidFill>
-                      <a:srgbClr val="1F3A68"/>
-                    </a:solidFill>
-                  </a:tcPr>
-                </a:tc>
-                <a:tc>
-                  <a:txBody>
-                    <a:bodyPr wrap="square"/>
-                    <a:lstStyle/>
-                    <a:p>
-                      <a:r>
-                        <a:rPr sz="1000" b="1">
-                          <a:solidFill>
-                            <a:srgbClr val="FFFFFF"/>
-                          </a:solidFill>
-                        </a:rPr>
-                        <a:t>4-й</a:t>
-                      </a:r>
-                    </a:p>
-                  </a:txBody>
-                  <a:tcPr marL="36000" marR="36000" marT="18000" marB="18000">
-                    <a:solidFill>
-                      <a:srgbClr val="1F3A68"/>
-                    </a:solidFill>
-                  </a:tcPr>
-                </a:tc>
-                <a:tc>
-                  <a:txBody>
-                    <a:bodyPr wrap="square"/>
-                    <a:lstStyle/>
-                    <a:p>
-                      <a:r>
-                        <a:rPr sz="1000" b="1">
-                          <a:solidFill>
-                            <a:srgbClr val="FFFFFF"/>
-                          </a:solidFill>
-                        </a:rPr>
-                        <a:t>5-й</a:t>
-                      </a:r>
-                    </a:p>
-                  </a:txBody>
-                  <a:tcPr marL="36000" marR="36000" marT="18000" marB="18000">
-                    <a:solidFill>
-                      <a:srgbClr val="1F3A68"/>
-                    </a:solidFill>
-                  </a:tcPr>
-                </a:tc>
               </a:tr>
-              <a:tr h="330000">
+              <a:tr h="160000">
                 <a:tc>
                   <a:txBody>
                     <a:bodyPr wrap="square"/>
@@ -7124,7 +6517,7 @@
                     <a:p>
                       <a:r>
                         <a:rPr sz="900" b="1"/>
-                        <a:t>Сеть фирменных магазинов</a:t>
+                        <a:t>Производственное оборудование</a:t>
                       </a:r>
                     </a:p>
                   </a:txBody>
@@ -7137,7 +6530,22 @@
                     <a:p>
                       <a:r>
                         <a:rPr sz="900"/>
-                        <a:t>41,2</a:t>
+                        <a:t>28,5</a:t>
+                      </a:r>
+                    </a:p>
+                  </a:txBody>
+                  <a:tcPr marL="36000" marR="36000" marT="18000" marB="18000"/>
+                </a:tc>
+              </a:tr>
+              <a:tr h="160000">
+                <a:tc>
+                  <a:txBody>
+                    <a:bodyPr wrap="square"/>
+                    <a:lstStyle/>
+                    <a:p>
+                      <a:r>
+                        <a:rPr sz="900" b="1"/>
+                        <a:t>Реконструкция и сети</a:t>
                       </a:r>
                     </a:p>
                   </a:txBody>
@@ -7150,7 +6558,22 @@
                     <a:p>
                       <a:r>
                         <a:rPr sz="900"/>
-                        <a:t>98,4</a:t>
+                        <a:t>8,2</a:t>
+                      </a:r>
+                    </a:p>
+                  </a:txBody>
+                  <a:tcPr marL="36000" marR="36000" marT="18000" marB="18000"/>
+                </a:tc>
+              </a:tr>
+              <a:tr h="160000">
+                <a:tc>
+                  <a:txBody>
+                    <a:bodyPr wrap="square"/>
+                    <a:lstStyle/>
+                    <a:p>
+                      <a:r>
+                        <a:rPr sz="900" b="1"/>
+                        <a:t>Оборудование 5 магазинов</a:t>
                       </a:r>
                     </a:p>
                   </a:txBody>
@@ -7163,7 +6586,22 @@
                     <a:p>
                       <a:r>
                         <a:rPr sz="900"/>
-                        <a:t>157,3</a:t>
+                        <a:t>14,5</a:t>
+                      </a:r>
+                    </a:p>
+                  </a:txBody>
+                  <a:tcPr marL="36000" marR="36000" marT="18000" marB="18000"/>
+                </a:tc>
+              </a:tr>
+              <a:tr h="160000">
+                <a:tc>
+                  <a:txBody>
+                    <a:bodyPr wrap="square"/>
+                    <a:lstStyle/>
+                    <a:p>
+                      <a:r>
+                        <a:rPr sz="900" b="1"/>
+                        <a:t>Транспорт и цифровизация</a:t>
                       </a:r>
                     </a:p>
                   </a:txBody>
@@ -7176,7 +6614,22 @@
                     <a:p>
                       <a:r>
                         <a:rPr sz="900"/>
-                        <a:t>176,8</a:t>
+                        <a:t>9,8</a:t>
+                      </a:r>
+                    </a:p>
+                  </a:txBody>
+                  <a:tcPr marL="36000" marR="36000" marT="18000" marB="18000"/>
+                </a:tc>
+              </a:tr>
+              <a:tr h="160000">
+                <a:tc>
+                  <a:txBody>
+                    <a:bodyPr wrap="square"/>
+                    <a:lstStyle/>
+                    <a:p>
+                      <a:r>
+                        <a:rPr sz="900" b="1"/>
+                        <a:t>Лаборатория, ТМ и сертификация</a:t>
                       </a:r>
                     </a:p>
                   </a:txBody>
@@ -7189,14 +6642,14 @@
                     <a:p>
                       <a:r>
                         <a:rPr sz="900"/>
-                        <a:t>191,0</a:t>
+                        <a:t>5,6</a:t>
                       </a:r>
                     </a:p>
                   </a:txBody>
                   <a:tcPr marL="36000" marR="36000" marT="18000" marB="18000"/>
                 </a:tc>
               </a:tr>
-              <a:tr h="330000">
+              <a:tr h="160000">
                 <a:tc>
                   <a:txBody>
                     <a:bodyPr wrap="square"/>
@@ -7204,7 +6657,7 @@
                     <a:p>
                       <a:r>
                         <a:rPr sz="900" b="1"/>
-                        <a:t>Интернет-площадка</a:t>
+                        <a:t>Стартовый запас и маркетинг</a:t>
                       </a:r>
                     </a:p>
                   </a:txBody>
@@ -7217,7 +6670,22 @@
                     <a:p>
                       <a:r>
                         <a:rPr sz="900"/>
-                        <a:t>6,8</a:t>
+                        <a:t>8,5</a:t>
+                      </a:r>
+                    </a:p>
+                  </a:txBody>
+                  <a:tcPr marL="36000" marR="36000" marT="18000" marB="18000"/>
+                </a:tc>
+              </a:tr>
+              <a:tr h="160000">
+                <a:tc>
+                  <a:txBody>
+                    <a:bodyPr wrap="square"/>
+                    <a:lstStyle/>
+                    <a:p>
+                      <a:r>
+                        <a:rPr sz="900" b="1"/>
+                        <a:t>Резерв (4,4 %)</a:t>
                       </a:r>
                     </a:p>
                   </a:txBody>
@@ -7230,7 +6698,22 @@
                     <a:p>
                       <a:r>
                         <a:rPr sz="900"/>
-                        <a:t>18,0</a:t>
+                        <a:t>3,4</a:t>
+                      </a:r>
+                    </a:p>
+                  </a:txBody>
+                  <a:tcPr marL="36000" marR="36000" marT="18000" marB="18000"/>
+                </a:tc>
+              </a:tr>
+              <a:tr h="160000">
+                <a:tc>
+                  <a:txBody>
+                    <a:bodyPr wrap="square"/>
+                    <a:lstStyle/>
+                    <a:p>
+                      <a:r>
+                        <a:rPr sz="900" b="1"/>
+                        <a:t>Итого CapEx</a:t>
                       </a:r>
                     </a:p>
                   </a:txBody>
@@ -7243,273 +6726,7 @@
                     <a:p>
                       <a:r>
                         <a:rPr sz="900"/>
-                        <a:t>35,0</a:t>
-                      </a:r>
-                    </a:p>
-                  </a:txBody>
-                  <a:tcPr marL="36000" marR="36000" marT="18000" marB="18000"/>
-                </a:tc>
-                <a:tc>
-                  <a:txBody>
-                    <a:bodyPr wrap="square"/>
-                    <a:lstStyle/>
-                    <a:p>
-                      <a:r>
-                        <a:rPr sz="900"/>
-                        <a:t>42,8</a:t>
-                      </a:r>
-                    </a:p>
-                  </a:txBody>
-                  <a:tcPr marL="36000" marR="36000" marT="18000" marB="18000"/>
-                </a:tc>
-                <a:tc>
-                  <a:txBody>
-                    <a:bodyPr wrap="square"/>
-                    <a:lstStyle/>
-                    <a:p>
-                      <a:r>
-                        <a:rPr sz="900"/>
-                        <a:t>49,5</a:t>
-                      </a:r>
-                    </a:p>
-                  </a:txBody>
-                  <a:tcPr marL="36000" marR="36000" marT="18000" marB="18000"/>
-                </a:tc>
-              </a:tr>
-              <a:tr h="330000">
-                <a:tc>
-                  <a:txBody>
-                    <a:bodyPr wrap="square"/>
-                    <a:lstStyle/>
-                    <a:p>
-                      <a:r>
-                        <a:rPr sz="900" b="1"/>
-                        <a:t>Оптовые каналы</a:t>
-                      </a:r>
-                    </a:p>
-                  </a:txBody>
-                  <a:tcPr marL="36000" marR="36000" marT="18000" marB="18000"/>
-                </a:tc>
-                <a:tc>
-                  <a:txBody>
-                    <a:bodyPr wrap="square"/>
-                    <a:lstStyle/>
-                    <a:p>
-                      <a:r>
-                        <a:rPr sz="900"/>
-                        <a:t>4,5</a:t>
-                      </a:r>
-                    </a:p>
-                  </a:txBody>
-                  <a:tcPr marL="36000" marR="36000" marT="18000" marB="18000"/>
-                </a:tc>
-                <a:tc>
-                  <a:txBody>
-                    <a:bodyPr wrap="square"/>
-                    <a:lstStyle/>
-                    <a:p>
-                      <a:r>
-                        <a:rPr sz="900"/>
-                        <a:t>11,0</a:t>
-                      </a:r>
-                    </a:p>
-                  </a:txBody>
-                  <a:tcPr marL="36000" marR="36000" marT="18000" marB="18000"/>
-                </a:tc>
-                <a:tc>
-                  <a:txBody>
-                    <a:bodyPr wrap="square"/>
-                    <a:lstStyle/>
-                    <a:p>
-                      <a:r>
-                        <a:rPr sz="900"/>
-                        <a:t>26,1</a:t>
-                      </a:r>
-                    </a:p>
-                  </a:txBody>
-                  <a:tcPr marL="36000" marR="36000" marT="18000" marB="18000"/>
-                </a:tc>
-                <a:tc>
-                  <a:txBody>
-                    <a:bodyPr wrap="square"/>
-                    <a:lstStyle/>
-                    <a:p>
-                      <a:r>
-                        <a:rPr sz="900"/>
-                        <a:t>32,4</a:t>
-                      </a:r>
-                    </a:p>
-                  </a:txBody>
-                  <a:tcPr marL="36000" marR="36000" marT="18000" marB="18000"/>
-                </a:tc>
-                <a:tc>
-                  <a:txBody>
-                    <a:bodyPr wrap="square"/>
-                    <a:lstStyle/>
-                    <a:p>
-                      <a:r>
-                        <a:rPr sz="900"/>
-                        <a:t>38,0</a:t>
-                      </a:r>
-                    </a:p>
-                  </a:txBody>
-                  <a:tcPr marL="36000" marR="36000" marT="18000" marB="18000"/>
-                </a:tc>
-              </a:tr>
-              <a:tr h="330000">
-                <a:tc>
-                  <a:txBody>
-                    <a:bodyPr wrap="square"/>
-                    <a:lstStyle/>
-                    <a:p>
-                      <a:r>
-                        <a:rPr sz="900" b="1"/>
-                        <a:t>Итого выручка</a:t>
-                      </a:r>
-                    </a:p>
-                  </a:txBody>
-                  <a:tcPr marL="36000" marR="36000" marT="18000" marB="18000"/>
-                </a:tc>
-                <a:tc>
-                  <a:txBody>
-                    <a:bodyPr wrap="square"/>
-                    <a:lstStyle/>
-                    <a:p>
-                      <a:r>
-                        <a:rPr sz="900"/>
-                        <a:t>52,5</a:t>
-                      </a:r>
-                    </a:p>
-                  </a:txBody>
-                  <a:tcPr marL="36000" marR="36000" marT="18000" marB="18000"/>
-                </a:tc>
-                <a:tc>
-                  <a:txBody>
-                    <a:bodyPr wrap="square"/>
-                    <a:lstStyle/>
-                    <a:p>
-                      <a:r>
-                        <a:rPr sz="900"/>
-                        <a:t>127,4</a:t>
-                      </a:r>
-                    </a:p>
-                  </a:txBody>
-                  <a:tcPr marL="36000" marR="36000" marT="18000" marB="18000"/>
-                </a:tc>
-                <a:tc>
-                  <a:txBody>
-                    <a:bodyPr wrap="square"/>
-                    <a:lstStyle/>
-                    <a:p>
-                      <a:r>
-                        <a:rPr sz="900"/>
-                        <a:t>218,4</a:t>
-                      </a:r>
-                    </a:p>
-                  </a:txBody>
-                  <a:tcPr marL="36000" marR="36000" marT="18000" marB="18000"/>
-                </a:tc>
-                <a:tc>
-                  <a:txBody>
-                    <a:bodyPr wrap="square"/>
-                    <a:lstStyle/>
-                    <a:p>
-                      <a:r>
-                        <a:rPr sz="900"/>
-                        <a:t>252,0</a:t>
-                      </a:r>
-                    </a:p>
-                  </a:txBody>
-                  <a:tcPr marL="36000" marR="36000" marT="18000" marB="18000"/>
-                </a:tc>
-                <a:tc>
-                  <a:txBody>
-                    <a:bodyPr wrap="square"/>
-                    <a:lstStyle/>
-                    <a:p>
-                      <a:r>
-                        <a:rPr sz="900"/>
-                        <a:t>278,5</a:t>
-                      </a:r>
-                    </a:p>
-                  </a:txBody>
-                  <a:tcPr marL="36000" marR="36000" marT="18000" marB="18000"/>
-                </a:tc>
-              </a:tr>
-              <a:tr h="330000">
-                <a:tc>
-                  <a:txBody>
-                    <a:bodyPr wrap="square"/>
-                    <a:lstStyle/>
-                    <a:p>
-                      <a:r>
-                        <a:rPr sz="900" b="1"/>
-                        <a:t>Чистая прибыль, тыс. руб.</a:t>
-                      </a:r>
-                    </a:p>
-                  </a:txBody>
-                  <a:tcPr marL="36000" marR="36000" marT="18000" marB="18000"/>
-                </a:tc>
-                <a:tc>
-                  <a:txBody>
-                    <a:bodyPr wrap="square"/>
-                    <a:lstStyle/>
-                    <a:p>
-                      <a:r>
-                        <a:rPr sz="900"/>
-                        <a:t>1 120</a:t>
-                      </a:r>
-                    </a:p>
-                  </a:txBody>
-                  <a:tcPr marL="36000" marR="36000" marT="18000" marB="18000"/>
-                </a:tc>
-                <a:tc>
-                  <a:txBody>
-                    <a:bodyPr wrap="square"/>
-                    <a:lstStyle/>
-                    <a:p>
-                      <a:r>
-                        <a:rPr sz="900"/>
-                        <a:t>18 240</a:t>
-                      </a:r>
-                    </a:p>
-                  </a:txBody>
-                  <a:tcPr marL="36000" marR="36000" marT="18000" marB="18000"/>
-                </a:tc>
-                <a:tc>
-                  <a:txBody>
-                    <a:bodyPr wrap="square"/>
-                    <a:lstStyle/>
-                    <a:p>
-                      <a:r>
-                        <a:rPr sz="900"/>
-                        <a:t>46 400</a:t>
-                      </a:r>
-                    </a:p>
-                  </a:txBody>
-                  <a:tcPr marL="36000" marR="36000" marT="18000" marB="18000"/>
-                </a:tc>
-                <a:tc>
-                  <a:txBody>
-                    <a:bodyPr wrap="square"/>
-                    <a:lstStyle/>
-                    <a:p>
-                      <a:r>
-                        <a:rPr sz="900"/>
-                        <a:t>58 640</a:t>
-                      </a:r>
-                    </a:p>
-                  </a:txBody>
-                  <a:tcPr marL="36000" marR="36000" marT="18000" marB="18000"/>
-                </a:tc>
-                <a:tc>
-                  <a:txBody>
-                    <a:bodyPr wrap="square"/>
-                    <a:lstStyle/>
-                    <a:p>
-                      <a:r>
-                        <a:rPr sz="900"/>
-                        <a:t>68 480</a:t>
+                        <a:t>78,5</a:t>
                       </a:r>
                     </a:p>
                   </a:txBody>
@@ -7529,8 +6746,8 @@
           <p:nvPr/>
         </p:nvGraphicFramePr>
         <p:xfrm>
-          <a:off x="4428000" y="3600000"/>
-          <a:ext cx="4464000" cy="1800000"/>
+          <a:off x="4572000" y="4896000"/>
+          <a:ext cx="4428000" cy="1440000"/>
         </p:xfrm>
         <a:graphic>
           <a:graphicData uri="http://schemas.openxmlformats.org/drawingml/2006/table">
@@ -7539,18 +6756,18 @@
                 <a:tableStyleId>{5C22544A-7EE6-4342-B048-85BDC9FD1C3A}</a:tableStyleId>
               </a:tblPr>
               <a:tblGrid>
-                <a:gridCol w="1488000"/>
-                <a:gridCol w="1488000"/>
-                <a:gridCol w="1488000"/>
+                <a:gridCol w="1476000"/>
+                <a:gridCol w="1476000"/>
+                <a:gridCol w="1476000"/>
               </a:tblGrid>
-              <a:tr h="300000">
-                <a:tc>
-                  <a:txBody>
-                    <a:bodyPr wrap="square"/>
-                    <a:lstStyle/>
-                    <a:p>
-                      <a:r>
-                        <a:rPr sz="1100" b="1">
+              <a:tr h="240000">
+                <a:tc>
+                  <a:txBody>
+                    <a:bodyPr wrap="square"/>
+                    <a:lstStyle/>
+                    <a:p>
+                      <a:r>
+                        <a:rPr sz="1000" b="1">
                           <a:solidFill>
                             <a:srgbClr val="FFFFFF"/>
                           </a:solidFill>
@@ -7571,7 +6788,7 @@
                     <a:lstStyle/>
                     <a:p>
                       <a:r>
-                        <a:rPr sz="1100" b="1">
+                        <a:rPr sz="1000" b="1">
                           <a:solidFill>
                             <a:srgbClr val="FFFFFF"/>
                           </a:solidFill>
@@ -7592,12 +6809,12 @@
                     <a:lstStyle/>
                     <a:p>
                       <a:r>
-                        <a:rPr sz="1100" b="1">
+                        <a:rPr sz="1000" b="1">
                           <a:solidFill>
                             <a:srgbClr val="FFFFFF"/>
                           </a:solidFill>
                         </a:rPr>
-                        <a:t>Норматив</a:t>
+                        <a:t>Норма</a:t>
                       </a:r>
                     </a:p>
                   </a:txBody>
@@ -7608,14 +6825,14 @@
                   </a:tcPr>
                 </a:tc>
               </a:tr>
-              <a:tr h="300000">
-                <a:tc>
-                  <a:txBody>
-                    <a:bodyPr wrap="square"/>
-                    <a:lstStyle/>
-                    <a:p>
-                      <a:r>
-                        <a:rPr sz="1000" b="1"/>
+              <a:tr h="240000">
+                <a:tc>
+                  <a:txBody>
+                    <a:bodyPr wrap="square"/>
+                    <a:lstStyle/>
+                    <a:p>
+                      <a:r>
+                        <a:rPr sz="900" b="1"/>
                         <a:t>NPV (r = 20 %)</a:t>
                       </a:r>
                     </a:p>
@@ -7628,7 +6845,7 @@
                     <a:lstStyle/>
                     <a:p>
                       <a:r>
-                        <a:rPr sz="1000"/>
+                        <a:rPr sz="900"/>
                         <a:t>47,2 млн руб.</a:t>
                       </a:r>
                     </a:p>
@@ -7641,7 +6858,7 @@
                     <a:lstStyle/>
                     <a:p>
                       <a:r>
-                        <a:rPr sz="1000"/>
+                        <a:rPr sz="900"/>
                         <a:t>&gt; 0</a:t>
                       </a:r>
                     </a:p>
@@ -7649,14 +6866,14 @@
                   <a:tcPr marL="36000" marR="36000" marT="18000" marB="18000"/>
                 </a:tc>
               </a:tr>
-              <a:tr h="300000">
-                <a:tc>
-                  <a:txBody>
-                    <a:bodyPr wrap="square"/>
-                    <a:lstStyle/>
-                    <a:p>
-                      <a:r>
-                        <a:rPr sz="1000" b="1"/>
+              <a:tr h="240000">
+                <a:tc>
+                  <a:txBody>
+                    <a:bodyPr wrap="square"/>
+                    <a:lstStyle/>
+                    <a:p>
+                      <a:r>
+                        <a:rPr sz="900" b="1"/>
                         <a:t>IRR</a:t>
                       </a:r>
                     </a:p>
@@ -7669,7 +6886,7 @@
                     <a:lstStyle/>
                     <a:p>
                       <a:r>
-                        <a:rPr sz="1000"/>
+                        <a:rPr sz="900"/>
                         <a:t>32,4 %</a:t>
                       </a:r>
                     </a:p>
@@ -7682,7 +6899,7 @@
                     <a:lstStyle/>
                     <a:p>
                       <a:r>
-                        <a:rPr sz="1000"/>
+                        <a:rPr sz="900"/>
                         <a:t>&gt; r</a:t>
                       </a:r>
                     </a:p>
@@ -7690,14 +6907,14 @@
                   <a:tcPr marL="36000" marR="36000" marT="18000" marB="18000"/>
                 </a:tc>
               </a:tr>
-              <a:tr h="300000">
-                <a:tc>
-                  <a:txBody>
-                    <a:bodyPr wrap="square"/>
-                    <a:lstStyle/>
-                    <a:p>
-                      <a:r>
-                        <a:rPr sz="1000" b="1"/>
+              <a:tr h="240000">
+                <a:tc>
+                  <a:txBody>
+                    <a:bodyPr wrap="square"/>
+                    <a:lstStyle/>
+                    <a:p>
+                      <a:r>
+                        <a:rPr sz="900" b="1"/>
                         <a:t>PI</a:t>
                       </a:r>
                     </a:p>
@@ -7710,7 +6927,7 @@
                     <a:lstStyle/>
                     <a:p>
                       <a:r>
-                        <a:rPr sz="1000"/>
+                        <a:rPr sz="900"/>
                         <a:t>1,60</a:t>
                       </a:r>
                     </a:p>
@@ -7723,7 +6940,7 @@
                     <a:lstStyle/>
                     <a:p>
                       <a:r>
-                        <a:rPr sz="1000"/>
+                        <a:rPr sz="900"/>
                         <a:t>&gt; 1</a:t>
                       </a:r>
                     </a:p>
@@ -7731,14 +6948,14 @@
                   <a:tcPr marL="36000" marR="36000" marT="18000" marB="18000"/>
                 </a:tc>
               </a:tr>
-              <a:tr h="300000">
-                <a:tc>
-                  <a:txBody>
-                    <a:bodyPr wrap="square"/>
-                    <a:lstStyle/>
-                    <a:p>
-                      <a:r>
-                        <a:rPr sz="1000" b="1"/>
+              <a:tr h="240000">
+                <a:tc>
+                  <a:txBody>
+                    <a:bodyPr wrap="square"/>
+                    <a:lstStyle/>
+                    <a:p>
+                      <a:r>
+                        <a:rPr sz="900" b="1"/>
                         <a:t>DPP (с тер. ст.)</a:t>
                       </a:r>
                     </a:p>
@@ -7751,7 +6968,7 @@
                     <a:lstStyle/>
                     <a:p>
                       <a:r>
-                        <a:rPr sz="1000"/>
+                        <a:rPr sz="900"/>
                         <a:t>3,2 года</a:t>
                       </a:r>
                     </a:p>
@@ -7764,7 +6981,7 @@
                     <a:lstStyle/>
                     <a:p>
                       <a:r>
-                        <a:rPr sz="1000"/>
+                        <a:rPr sz="900"/>
                         <a:t>&lt; 5 лет</a:t>
                       </a:r>
                     </a:p>
@@ -7772,14 +6989,14 @@
                   <a:tcPr marL="36000" marR="36000" marT="18000" marB="18000"/>
                 </a:tc>
               </a:tr>
-              <a:tr h="300000">
-                <a:tc>
-                  <a:txBody>
-                    <a:bodyPr wrap="square"/>
-                    <a:lstStyle/>
-                    <a:p>
-                      <a:r>
-                        <a:rPr sz="1000" b="1"/>
+              <a:tr h="240000">
+                <a:tc>
+                  <a:txBody>
+                    <a:bodyPr wrap="square"/>
+                    <a:lstStyle/>
+                    <a:p>
+                      <a:r>
+                        <a:rPr sz="900" b="1"/>
                         <a:t>E(NPV) сценарного анализа</a:t>
                       </a:r>
                     </a:p>
@@ -7792,7 +7009,7 @@
                     <a:lstStyle/>
                     <a:p>
                       <a:r>
-                        <a:rPr sz="1000"/>
+                        <a:rPr sz="900"/>
                         <a:t>42,6 млн руб.</a:t>
                       </a:r>
                     </a:p>
@@ -7805,7 +7022,7 @@
                     <a:lstStyle/>
                     <a:p>
                       <a:r>
-                        <a:rPr sz="1000"/>
+                        <a:rPr sz="900"/>
                         <a:t>&gt; 0</a:t>
                       </a:r>
                     </a:p>
@@ -7817,35 +7034,6 @@
           </a:graphicData>
         </a:graphic>
       </p:graphicFrame>
-      <p:sp>
-        <p:nvSpPr>
-          <p:cNvPr id="6" name="TextBox 5"/>
-          <p:cNvSpPr txBox="1"/>
-          <p:nvPr/>
-        </p:nvSpPr>
-        <p:spPr>
-          <a:xfrm>
-            <a:off x="216000" y="5616000"/>
-            <a:ext cx="8676000" cy="648000"/>
-          </a:xfrm>
-          <a:prstGeom prst="rect">
-            <a:avLst/>
-          </a:prstGeom>
-          <a:noFill/>
-        </p:spPr>
-        <p:txBody>
-          <a:bodyPr wrap="square">
-            <a:spAutoFit/>
-          </a:bodyPr>
-          <a:lstStyle/>
-          <a:p>
-            <a:r>
-              <a:rPr sz="1100" b="0" i="1"/>
-              <a:t>Вывод: проект коммерчески эффективен — все 4 критерия (NPV &gt; 0, IRR &gt; r, PI &gt; 1, DPP &lt; 5 лет) выполнены. PSM = 29,1 тыс. руб./м²/мес. в коридоре нормы. Стресс-тест проекта — устойчивость к одиночному риску ±10 %.</a:t>
-            </a:r>
-          </a:p>
-        </p:txBody>
-      </p:sp>
     </p:spTree>
   </p:cSld>
   <p:clrMapOvr>

</xml_diff>